<commit_message>
Pesi per categoria: struttura, bulloneria, elettromeccanico, elettronico
- compute: pesi per categoria totali e per riga tracker (R.pesi, righe[i].pesi).
- Costi: pesi per categoria e totale nel riepilogo; tabella per riga con
  componenti di impianto e peso per singolo tracker.
- Excel di lavorazione: pesi per categoria nel foglio Commessa.
- Offerta: fascia "PESI DELLA FORNITURA" nella slide Dati di progetto
  ({{peso_struttura}}, {{peso_bulloneria}}, {{peso_elettromeccanico}},
  {{peso_elettronico}}, {{peso_totale}}).

Co-Authored-By: Claude Opus 5.5 <noreply@anthropic.com>
</commit_message>
<xml_diff>
--- a/public/offerta/modello-offerta.pptx
+++ b/public/offerta/modello-offerta.pptx
@@ -11591,6 +11591,455 @@
                 <a:sym typeface="Canva Sans"/>
               </a:rPr>
               <a:t xml:space="preserve">* Profondità di infissione da validare con pull-out test o studio geotecnico. Moduli non inclusi nella fornitura.</a:t>
+            </a:r>
+          </a:p>
+        </p:txBody>
+      </p:sp>
+      <p:sp>
+        <p:nvSpPr>
+          <p:cNvPr id="200" name="Card pesi"/>
+          <p:cNvSpPr/>
+          <p:nvPr/>
+        </p:nvSpPr>
+        <p:spPr>
+          <a:xfrm>
+            <a:off x="6200000" y="8050000"/>
+            <a:ext cx="10887911" cy="1500000"/>
+          </a:xfrm>
+          <a:prstGeom prst="roundRect">
+            <a:avLst>
+              <a:gd name="adj" fmla="val 12000"/>
+            </a:avLst>
+          </a:prstGeom>
+          <a:solidFill>
+            <a:srgbClr val="FFFFFF">
+              <a:alpha val="7000"/>
+            </a:srgbClr>
+          </a:solidFill>
+          <a:ln w="19050">
+            <a:solidFill>
+              <a:srgbClr val="79E920"/>
+            </a:solidFill>
+          </a:ln>
+        </p:spPr>
+        <p:txBody>
+          <a:bodyPr/>
+          <a:lstStyle/>
+          <a:p>
+            <a:endParaRPr lang="it-IT"/>
+          </a:p>
+        </p:txBody>
+      </p:sp>
+      <p:sp>
+        <p:nvSpPr>
+          <p:cNvPr id="201" name="Card text 4"/>
+          <p:cNvSpPr txBox="1"/>
+          <p:nvPr/>
+        </p:nvSpPr>
+        <p:spPr>
+          <a:xfrm>
+            <a:off x="6480000" y="8050000"/>
+            <a:ext cx="1900000" cy="1500000"/>
+          </a:xfrm>
+          <a:prstGeom prst="rect">
+            <a:avLst/>
+          </a:prstGeom>
+          <a:noFill/>
+        </p:spPr>
+        <p:txBody>
+          <a:bodyPr wrap="square" lIns="0" tIns="0" rIns="0" bIns="0" rtlCol="0" anchor="ctr">
+            <a:noAutofit/>
+          </a:bodyPr>
+          <a:lstStyle/>
+          <a:p>
+            <a:pPr algn="l">
+              <a:lnSpc>
+                <a:spcPts val="2400"/>
+              </a:lnSpc>
+              <a:spcAft>
+                <a:spcPts val="0"/>
+              </a:spcAft>
+              <a:buNone/>
+            </a:pPr>
+            <a:r>
+              <a:rPr lang="it-IT" sz="2000" b="1" dirty="0">
+                <a:solidFill>
+                  <a:srgbClr val="79E920"/>
+                </a:solidFill>
+                <a:latin typeface="Open Sauce Bold"/>
+                <a:ea typeface="Open Sauce Bold"/>
+                <a:cs typeface="Open Sauce Bold"/>
+                <a:sym typeface="Open Sauce Bold"/>
+              </a:rPr>
+              <a:t xml:space="preserve">PESI DELLA</a:t>
+            </a:r>
+          </a:p>
+          <a:p>
+            <a:pPr algn="l">
+              <a:lnSpc>
+                <a:spcPts val="2400"/>
+              </a:lnSpc>
+              <a:spcAft>
+                <a:spcPts val="0"/>
+              </a:spcAft>
+              <a:buNone/>
+            </a:pPr>
+            <a:r>
+              <a:rPr lang="it-IT" sz="2000" b="1" dirty="0">
+                <a:solidFill>
+                  <a:srgbClr val="79E920"/>
+                </a:solidFill>
+                <a:latin typeface="Open Sauce Bold"/>
+                <a:ea typeface="Open Sauce Bold"/>
+                <a:cs typeface="Open Sauce Bold"/>
+                <a:sym typeface="Open Sauce Bold"/>
+              </a:rPr>
+              <a:t xml:space="preserve">FORNITURA</a:t>
+            </a:r>
+          </a:p>
+        </p:txBody>
+      </p:sp>
+      <p:sp>
+        <p:nvSpPr>
+          <p:cNvPr id="202" name="Peso Struttura"/>
+          <p:cNvSpPr txBox="1"/>
+          <p:nvPr/>
+        </p:nvSpPr>
+        <p:spPr>
+          <a:xfrm>
+            <a:off x="8380000" y="8050000"/>
+            <a:ext cx="1685582" cy="1500000"/>
+          </a:xfrm>
+          <a:prstGeom prst="rect">
+            <a:avLst/>
+          </a:prstGeom>
+          <a:noFill/>
+        </p:spPr>
+        <p:txBody>
+          <a:bodyPr wrap="square" lIns="0" tIns="0" rIns="0" bIns="0" rtlCol="0" anchor="ctr">
+            <a:noAutofit/>
+          </a:bodyPr>
+          <a:lstStyle/>
+          <a:p>
+            <a:pPr algn="l">
+              <a:lnSpc>
+                <a:spcPts val="2000"/>
+              </a:lnSpc>
+              <a:spcAft>
+                <a:spcPts val="0"/>
+              </a:spcAft>
+              <a:buNone/>
+            </a:pPr>
+            <a:r>
+              <a:rPr lang="it-IT" sz="1500" dirty="0">
+                <a:solidFill>
+                  <a:srgbClr val="FFFFFF"/>
+                </a:solidFill>
+                <a:latin typeface="Canva Sans"/>
+                <a:ea typeface="Canva Sans"/>
+                <a:cs typeface="Canva Sans"/>
+                <a:sym typeface="Canva Sans"/>
+              </a:rPr>
+              <a:t xml:space="preserve">Struttura</a:t>
+            </a:r>
+          </a:p>
+          <a:p>
+            <a:pPr algn="l">
+              <a:lnSpc>
+                <a:spcPts val="2800"/>
+              </a:lnSpc>
+              <a:spcAft>
+                <a:spcPts val="0"/>
+              </a:spcAft>
+              <a:buNone/>
+            </a:pPr>
+            <a:r>
+              <a:rPr lang="it-IT" sz="2200" b="1" dirty="0">
+                <a:solidFill>
+                  <a:srgbClr val="79E920"/>
+                </a:solidFill>
+                <a:latin typeface="Open Sauce Bold"/>
+                <a:ea typeface="Open Sauce Bold"/>
+                <a:cs typeface="Open Sauce Bold"/>
+                <a:sym typeface="Open Sauce Bold"/>
+              </a:rPr>
+              <a:t xml:space="preserve">{{peso_struttura}}</a:t>
+            </a:r>
+          </a:p>
+        </p:txBody>
+      </p:sp>
+      <p:sp>
+        <p:nvSpPr>
+          <p:cNvPr id="203" name="Peso Bulloneria"/>
+          <p:cNvSpPr txBox="1"/>
+          <p:nvPr/>
+        </p:nvSpPr>
+        <p:spPr>
+          <a:xfrm>
+            <a:off x="10065582" y="8050000"/>
+            <a:ext cx="1685582" cy="1500000"/>
+          </a:xfrm>
+          <a:prstGeom prst="rect">
+            <a:avLst/>
+          </a:prstGeom>
+          <a:noFill/>
+        </p:spPr>
+        <p:txBody>
+          <a:bodyPr wrap="square" lIns="0" tIns="0" rIns="0" bIns="0" rtlCol="0" anchor="ctr">
+            <a:noAutofit/>
+          </a:bodyPr>
+          <a:lstStyle/>
+          <a:p>
+            <a:pPr algn="l">
+              <a:lnSpc>
+                <a:spcPts val="2000"/>
+              </a:lnSpc>
+              <a:spcAft>
+                <a:spcPts val="0"/>
+              </a:spcAft>
+              <a:buNone/>
+            </a:pPr>
+            <a:r>
+              <a:rPr lang="it-IT" sz="1500" dirty="0">
+                <a:solidFill>
+                  <a:srgbClr val="FFFFFF"/>
+                </a:solidFill>
+                <a:latin typeface="Canva Sans"/>
+                <a:ea typeface="Canva Sans"/>
+                <a:cs typeface="Canva Sans"/>
+                <a:sym typeface="Canva Sans"/>
+              </a:rPr>
+              <a:t xml:space="preserve">Bulloneria</a:t>
+            </a:r>
+          </a:p>
+          <a:p>
+            <a:pPr algn="l">
+              <a:lnSpc>
+                <a:spcPts val="2800"/>
+              </a:lnSpc>
+              <a:spcAft>
+                <a:spcPts val="0"/>
+              </a:spcAft>
+              <a:buNone/>
+            </a:pPr>
+            <a:r>
+              <a:rPr lang="it-IT" sz="2200" b="1" dirty="0">
+                <a:solidFill>
+                  <a:srgbClr val="79E920"/>
+                </a:solidFill>
+                <a:latin typeface="Open Sauce Bold"/>
+                <a:ea typeface="Open Sauce Bold"/>
+                <a:cs typeface="Open Sauce Bold"/>
+                <a:sym typeface="Open Sauce Bold"/>
+              </a:rPr>
+              <a:t xml:space="preserve">{{peso_bulloneria}}</a:t>
+            </a:r>
+          </a:p>
+        </p:txBody>
+      </p:sp>
+      <p:sp>
+        <p:nvSpPr>
+          <p:cNvPr id="204" name="Peso Elettromeccanico"/>
+          <p:cNvSpPr txBox="1"/>
+          <p:nvPr/>
+        </p:nvSpPr>
+        <p:spPr>
+          <a:xfrm>
+            <a:off x="11751164" y="8050000"/>
+            <a:ext cx="1685582" cy="1500000"/>
+          </a:xfrm>
+          <a:prstGeom prst="rect">
+            <a:avLst/>
+          </a:prstGeom>
+          <a:noFill/>
+        </p:spPr>
+        <p:txBody>
+          <a:bodyPr wrap="square" lIns="0" tIns="0" rIns="0" bIns="0" rtlCol="0" anchor="ctr">
+            <a:noAutofit/>
+          </a:bodyPr>
+          <a:lstStyle/>
+          <a:p>
+            <a:pPr algn="l">
+              <a:lnSpc>
+                <a:spcPts val="2000"/>
+              </a:lnSpc>
+              <a:spcAft>
+                <a:spcPts val="0"/>
+              </a:spcAft>
+              <a:buNone/>
+            </a:pPr>
+            <a:r>
+              <a:rPr lang="it-IT" sz="1500" dirty="0">
+                <a:solidFill>
+                  <a:srgbClr val="FFFFFF"/>
+                </a:solidFill>
+                <a:latin typeface="Canva Sans"/>
+                <a:ea typeface="Canva Sans"/>
+                <a:cs typeface="Canva Sans"/>
+                <a:sym typeface="Canva Sans"/>
+              </a:rPr>
+              <a:t xml:space="preserve">Elettromeccanico</a:t>
+            </a:r>
+          </a:p>
+          <a:p>
+            <a:pPr algn="l">
+              <a:lnSpc>
+                <a:spcPts val="2800"/>
+              </a:lnSpc>
+              <a:spcAft>
+                <a:spcPts val="0"/>
+              </a:spcAft>
+              <a:buNone/>
+            </a:pPr>
+            <a:r>
+              <a:rPr lang="it-IT" sz="2200" b="1" dirty="0">
+                <a:solidFill>
+                  <a:srgbClr val="79E920"/>
+                </a:solidFill>
+                <a:latin typeface="Open Sauce Bold"/>
+                <a:ea typeface="Open Sauce Bold"/>
+                <a:cs typeface="Open Sauce Bold"/>
+                <a:sym typeface="Open Sauce Bold"/>
+              </a:rPr>
+              <a:t xml:space="preserve">{{peso_elettromeccanico}}</a:t>
+            </a:r>
+          </a:p>
+        </p:txBody>
+      </p:sp>
+      <p:sp>
+        <p:nvSpPr>
+          <p:cNvPr id="205" name="Peso Elettronico"/>
+          <p:cNvSpPr txBox="1"/>
+          <p:nvPr/>
+        </p:nvSpPr>
+        <p:spPr>
+          <a:xfrm>
+            <a:off x="13436746" y="8050000"/>
+            <a:ext cx="1685582" cy="1500000"/>
+          </a:xfrm>
+          <a:prstGeom prst="rect">
+            <a:avLst/>
+          </a:prstGeom>
+          <a:noFill/>
+        </p:spPr>
+        <p:txBody>
+          <a:bodyPr wrap="square" lIns="0" tIns="0" rIns="0" bIns="0" rtlCol="0" anchor="ctr">
+            <a:noAutofit/>
+          </a:bodyPr>
+          <a:lstStyle/>
+          <a:p>
+            <a:pPr algn="l">
+              <a:lnSpc>
+                <a:spcPts val="2000"/>
+              </a:lnSpc>
+              <a:spcAft>
+                <a:spcPts val="0"/>
+              </a:spcAft>
+              <a:buNone/>
+            </a:pPr>
+            <a:r>
+              <a:rPr lang="it-IT" sz="1500" dirty="0">
+                <a:solidFill>
+                  <a:srgbClr val="FFFFFF"/>
+                </a:solidFill>
+                <a:latin typeface="Canva Sans"/>
+                <a:ea typeface="Canva Sans"/>
+                <a:cs typeface="Canva Sans"/>
+                <a:sym typeface="Canva Sans"/>
+              </a:rPr>
+              <a:t xml:space="preserve">Elettronico</a:t>
+            </a:r>
+          </a:p>
+          <a:p>
+            <a:pPr algn="l">
+              <a:lnSpc>
+                <a:spcPts val="2800"/>
+              </a:lnSpc>
+              <a:spcAft>
+                <a:spcPts val="0"/>
+              </a:spcAft>
+              <a:buNone/>
+            </a:pPr>
+            <a:r>
+              <a:rPr lang="it-IT" sz="2200" b="1" dirty="0">
+                <a:solidFill>
+                  <a:srgbClr val="79E920"/>
+                </a:solidFill>
+                <a:latin typeface="Open Sauce Bold"/>
+                <a:ea typeface="Open Sauce Bold"/>
+                <a:cs typeface="Open Sauce Bold"/>
+                <a:sym typeface="Open Sauce Bold"/>
+              </a:rPr>
+              <a:t xml:space="preserve">{{peso_elettronico}}</a:t>
+            </a:r>
+          </a:p>
+        </p:txBody>
+      </p:sp>
+      <p:sp>
+        <p:nvSpPr>
+          <p:cNvPr id="206" name="Peso Totale"/>
+          <p:cNvSpPr txBox="1"/>
+          <p:nvPr/>
+        </p:nvSpPr>
+        <p:spPr>
+          <a:xfrm>
+            <a:off x="15122328" y="8050000"/>
+            <a:ext cx="1685582" cy="1500000"/>
+          </a:xfrm>
+          <a:prstGeom prst="rect">
+            <a:avLst/>
+          </a:prstGeom>
+          <a:noFill/>
+        </p:spPr>
+        <p:txBody>
+          <a:bodyPr wrap="square" lIns="0" tIns="0" rIns="0" bIns="0" rtlCol="0" anchor="ctr">
+            <a:noAutofit/>
+          </a:bodyPr>
+          <a:lstStyle/>
+          <a:p>
+            <a:pPr algn="l">
+              <a:lnSpc>
+                <a:spcPts val="2000"/>
+              </a:lnSpc>
+              <a:spcAft>
+                <a:spcPts val="0"/>
+              </a:spcAft>
+              <a:buNone/>
+            </a:pPr>
+            <a:r>
+              <a:rPr lang="it-IT" sz="1500" dirty="0">
+                <a:solidFill>
+                  <a:srgbClr val="FFFFFF"/>
+                </a:solidFill>
+                <a:latin typeface="Canva Sans"/>
+                <a:ea typeface="Canva Sans"/>
+                <a:cs typeface="Canva Sans"/>
+                <a:sym typeface="Canva Sans"/>
+              </a:rPr>
+              <a:t xml:space="preserve">Totale</a:t>
+            </a:r>
+          </a:p>
+          <a:p>
+            <a:pPr algn="l">
+              <a:lnSpc>
+                <a:spcPts val="2800"/>
+              </a:lnSpc>
+              <a:spcAft>
+                <a:spcPts val="0"/>
+              </a:spcAft>
+              <a:buNone/>
+            </a:pPr>
+            <a:r>
+              <a:rPr lang="it-IT" sz="2200" b="1" dirty="0">
+                <a:solidFill>
+                  <a:srgbClr val="79E920"/>
+                </a:solidFill>
+                <a:latin typeface="Open Sauce Bold"/>
+                <a:ea typeface="Open Sauce Bold"/>
+                <a:cs typeface="Open Sauce Bold"/>
+                <a:sym typeface="Open Sauce Bold"/>
+              </a:rPr>
+              <a:t xml:space="preserve">{{peso_totale}}</a:t>
             </a:r>
           </a:p>
         </p:txBody>

</xml_diff>

<commit_message>
Offerta: slide layout vuota senza DXF né foto, garanzie a 30 pt su righe che non si sovrappongono
Co-Authored-By: Claude Opus 5.5 <noreply@anthropic.com>
</commit_message>
<xml_diff>
--- a/public/offerta/modello-offerta.pptx
+++ b/public/offerta/modello-offerta.pptx
@@ -8247,7 +8247,7 @@
           <a:p>
             <a:pPr marL="0" marR="0" lvl="0" indent="0" algn="l" defTabSz="914400" rtl="0" eaLnBrk="1" fontAlgn="auto" latinLnBrk="0" hangingPunct="1">
               <a:lnSpc>
-                <a:spcPts val="3570"/>
+                <a:spcPts val="3060"/>
               </a:lnSpc>
               <a:spcBef>
                 <a:spcPts val="0"/>
@@ -8263,7 +8263,7 @@
               <a:defRPr/>
             </a:pPr>
             <a:r>
-              <a:rPr kumimoji="0" lang="en-US" sz="3500" b="1" i="0" u="none" strike="noStrike" kern="1200" cap="none" spc="-171" normalizeH="0" baseline="0" noProof="0">
+              <a:rPr kumimoji="0" lang="en-US" sz="3000" b="1" i="0" u="none" strike="noStrike" kern="1200" cap="none" spc="-147" normalizeH="0" baseline="0" noProof="0">
                 <a:ln>
                   <a:noFill/>
                 </a:ln>
@@ -8284,7 +8284,7 @@
           <a:p>
             <a:pPr marL="0" marR="0" lvl="0" indent="0" algn="l" defTabSz="914400" rtl="0" eaLnBrk="1" fontAlgn="auto" latinLnBrk="0" hangingPunct="1">
               <a:lnSpc>
-                <a:spcPts val="2856"/>
+                <a:spcPts val="3060"/>
               </a:lnSpc>
               <a:spcBef>
                 <a:spcPts val="0"/>
@@ -8300,7 +8300,7 @@
               <a:defRPr/>
             </a:pPr>
             <a:r>
-              <a:rPr kumimoji="0" lang="en-US" sz="2800" b="1" i="0" u="none" strike="noStrike" kern="1200" cap="none" spc="-137" normalizeH="0" baseline="0" noProof="0">
+              <a:rPr kumimoji="0" lang="en-US" sz="3000" b="1" i="0" u="none" strike="noStrike" kern="1200" cap="none" spc="-147" normalizeH="0" baseline="0" noProof="0">
                 <a:ln>
                   <a:noFill/>
                 </a:ln>
@@ -8359,7 +8359,7 @@
               <a:defRPr/>
             </a:pPr>
             <a:r>
-              <a:rPr kumimoji="0" lang="en-US" sz="3500" b="1" i="0" u="none" strike="noStrike" kern="1200" cap="none" spc="-171" normalizeH="0" baseline="0" noProof="0">
+              <a:rPr kumimoji="0" lang="en-US" sz="3000" b="1" i="0" u="none" strike="noStrike" kern="1200" cap="none" spc="-147" normalizeH="0" baseline="0" noProof="0">
                 <a:ln>
                   <a:noFill/>
                 </a:ln>
@@ -8388,7 +8388,103 @@
         <p:spPr>
           <a:xfrm>
             <a:off x="1648039" y="5320505"/>
-            <a:ext cx="14909377" cy="596900"/>
+            <a:ext cx="14909377" cy="814959"/>
+          </a:xfrm>
+          <a:prstGeom prst="rect">
+            <a:avLst/>
+          </a:prstGeom>
+        </p:spPr>
+        <p:txBody>
+          <a:bodyPr lIns="0" tIns="0" rIns="0" bIns="0" rtlCol="0" anchor="t">
+            <a:spAutoFit/>
+          </a:bodyPr>
+          <a:lstStyle/>
+          <a:p>
+            <a:pPr marL="0" marR="0" lvl="0" indent="0" algn="l" defTabSz="914400" rtl="0" eaLnBrk="1" fontAlgn="auto" latinLnBrk="0" hangingPunct="1">
+              <a:lnSpc>
+                <a:spcPts val="3060"/>
+              </a:lnSpc>
+              <a:spcBef>
+                <a:spcPts val="0"/>
+              </a:spcBef>
+              <a:spcAft>
+                <a:spcPts val="0"/>
+              </a:spcAft>
+              <a:buClrTx/>
+              <a:buSzTx/>
+              <a:buFontTx/>
+              <a:buNone/>
+              <a:tabLst/>
+              <a:defRPr/>
+            </a:pPr>
+            <a:r>
+              <a:rPr kumimoji="0" lang="en-US" sz="3000" b="1" i="0" u="none" strike="noStrike" kern="1200" cap="none" spc="-147" normalizeH="0" baseline="0" noProof="0">
+                <a:ln>
+                  <a:noFill/>
+                </a:ln>
+                <a:solidFill>
+                  <a:srgbClr val="000000"/>
+                </a:solidFill>
+                <a:effectLst/>
+                <a:uLnTx/>
+                <a:uFillTx/>
+                <a:latin typeface="Open Sauce Bold"/>
+                <a:ea typeface="Open Sauce Bold"/>
+                <a:cs typeface="Open Sauce Bold"/>
+                <a:sym typeface="Open Sauce Bold"/>
+              </a:rPr>
+              <a:t>assistenza gratuita {{anni_assistenza_gratuita}} anni</a:t>
+            </a:r>
+          </a:p>
+          <a:p>
+            <a:pPr marL="0" marR="0" lvl="0" indent="0" algn="l" defTabSz="914400" rtl="0" eaLnBrk="1" fontAlgn="auto" latinLnBrk="0" hangingPunct="1">
+              <a:lnSpc>
+                <a:spcPts val="3060"/>
+              </a:lnSpc>
+              <a:spcBef>
+                <a:spcPts val="0"/>
+              </a:spcBef>
+              <a:spcAft>
+                <a:spcPts val="0"/>
+              </a:spcAft>
+              <a:buClrTx/>
+              <a:buSzTx/>
+              <a:buFontTx/>
+              <a:buNone/>
+              <a:tabLst/>
+              <a:defRPr/>
+            </a:pPr>
+            <a:r>
+              <a:rPr kumimoji="0" lang="en-US" sz="3000" b="1" i="0" u="none" strike="noStrike" kern="1200" cap="none" spc="-147" normalizeH="0" baseline="0" noProof="0">
+                <a:ln>
+                  <a:noFill/>
+                </a:ln>
+                <a:solidFill>
+                  <a:srgbClr val="000000"/>
+                </a:solidFill>
+                <a:effectLst/>
+                <a:uLnTx/>
+                <a:uFillTx/>
+                <a:latin typeface="Open Sauce Bold"/>
+                <a:ea typeface="Open Sauce Bold"/>
+                <a:cs typeface="Open Sauce Bold"/>
+                <a:sym typeface="Open Sauce Bold"/>
+              </a:rPr>
+              <a:t>e manutenzione programmata per tutta la vita utile</a:t>
+            </a:r>
+          </a:p>
+        </p:txBody>
+      </p:sp>
+      <p:sp>
+        <p:nvSpPr>
+          <p:cNvPr id="48" name="TextBox 48"/>
+          <p:cNvSpPr txBox="1"/>
+          <p:nvPr/>
+        </p:nvSpPr>
+        <p:spPr>
+          <a:xfrm>
+            <a:off x="1544292" y="6255096"/>
+            <a:ext cx="14559449" cy="596900"/>
           </a:xfrm>
           <a:prstGeom prst="rect">
             <a:avLst/>
@@ -8418,66 +8514,7 @@
               <a:defRPr/>
             </a:pPr>
             <a:r>
-              <a:rPr kumimoji="0" lang="en-US" sz="3500" b="1" i="0" u="none" strike="noStrike" kern="1200" cap="none" spc="-171" normalizeH="0" baseline="0" noProof="0">
-                <a:ln>
-                  <a:noFill/>
-                </a:ln>
-                <a:solidFill>
-                  <a:srgbClr val="000000"/>
-                </a:solidFill>
-                <a:effectLst/>
-                <a:uLnTx/>
-                <a:uFillTx/>
-                <a:latin typeface="Open Sauce Bold"/>
-                <a:ea typeface="Open Sauce Bold"/>
-                <a:cs typeface="Open Sauce Bold"/>
-                <a:sym typeface="Open Sauce Bold"/>
-              </a:rPr>
-              <a:t>assistenza gratuita {{anni_assistenza_gratuita}} anni e manutenzione programmata per tutta la vita utile</a:t>
-            </a:r>
-          </a:p>
-        </p:txBody>
-      </p:sp>
-      <p:sp>
-        <p:nvSpPr>
-          <p:cNvPr id="48" name="TextBox 48"/>
-          <p:cNvSpPr txBox="1"/>
-          <p:nvPr/>
-        </p:nvSpPr>
-        <p:spPr>
-          <a:xfrm>
-            <a:off x="1544292" y="6255096"/>
-            <a:ext cx="14559449" cy="596900"/>
-          </a:xfrm>
-          <a:prstGeom prst="rect">
-            <a:avLst/>
-          </a:prstGeom>
-        </p:spPr>
-        <p:txBody>
-          <a:bodyPr lIns="0" tIns="0" rIns="0" bIns="0" rtlCol="0" anchor="t">
-            <a:spAutoFit/>
-          </a:bodyPr>
-          <a:lstStyle/>
-          <a:p>
-            <a:pPr marL="0" marR="0" lvl="0" indent="0" algn="l" defTabSz="914400" rtl="0" eaLnBrk="1" fontAlgn="auto" latinLnBrk="0" hangingPunct="1">
-              <a:lnSpc>
-                <a:spcPts val="4900"/>
-              </a:lnSpc>
-              <a:spcBef>
-                <a:spcPct val="0"/>
-              </a:spcBef>
-              <a:spcAft>
-                <a:spcPts val="0"/>
-              </a:spcAft>
-              <a:buClrTx/>
-              <a:buSzTx/>
-              <a:buFontTx/>
-              <a:buNone/>
-              <a:tabLst/>
-              <a:defRPr/>
-            </a:pPr>
-            <a:r>
-              <a:rPr kumimoji="0" lang="en-US" sz="3500" b="1" i="0" u="none" strike="noStrike" kern="1200" cap="none" spc="-171" normalizeH="0" baseline="0" noProof="0">
+              <a:rPr kumimoji="0" lang="en-US" sz="3000" b="1" i="0" u="none" strike="noStrike" kern="1200" cap="none" spc="-147" normalizeH="0" baseline="0" noProof="0">
                 <a:ln>
                   <a:noFill/>
                 </a:ln>

</xml_diff>

<commit_message>
Servizi opzionali modificabili per preventivo (Invia preventivo e modulo Telegram): spunta, nome, prezzo, ordine, aggiunta; slide 9 con righe ripetute. Slide 5: riquadro Condizioni di progetto più largo
Co-Authored-By: Claude Opus 5.5 <noreply@anthropic.com>
</commit_message>
<xml_diff>
--- a/public/offerta/modello-offerta.pptx
+++ b/public/offerta/modello-offerta.pptx
@@ -16251,7 +16251,7 @@
         <p:spPr>
           <a:xfrm>
             <a:off x="11787911" y="2900000"/>
-            <a:ext cx="5300000" cy="4400000"/>
+            <a:ext cx="5888000" cy="4400000"/>
           </a:xfrm>
           <a:prstGeom prst="roundRect">
             <a:avLst>
@@ -16286,7 +16286,7 @@
         <p:spPr>
           <a:xfrm>
             <a:off x="12087911" y="3200000"/>
-            <a:ext cx="4700000" cy="3900000"/>
+            <a:ext cx="5288000" cy="3900000"/>
           </a:xfrm>
           <a:prstGeom prst="rect">
             <a:avLst/>
@@ -16689,7 +16689,7 @@
         <p:spPr>
           <a:xfrm>
             <a:off x="6200000" y="8050000"/>
-            <a:ext cx="10887911" cy="1500000"/>
+            <a:ext cx="11475911" cy="1500000"/>
           </a:xfrm>
           <a:prstGeom prst="roundRect">
             <a:avLst>
@@ -16793,7 +16793,7 @@
         <p:spPr>
           <a:xfrm>
             <a:off x="8380000" y="8050000"/>
-            <a:ext cx="1685582" cy="1500000"/>
+            <a:ext cx="1803182" cy="1500000"/>
           </a:xfrm>
           <a:prstGeom prst="rect">
             <a:avLst/>
@@ -16861,8 +16861,8 @@
         </p:nvSpPr>
         <p:spPr>
           <a:xfrm>
-            <a:off x="10065582" y="8050000"/>
-            <a:ext cx="1685582" cy="1500000"/>
+            <a:off x="10183182" y="8050000"/>
+            <a:ext cx="1803182" cy="1500000"/>
           </a:xfrm>
           <a:prstGeom prst="rect">
             <a:avLst/>
@@ -16930,8 +16930,8 @@
         </p:nvSpPr>
         <p:spPr>
           <a:xfrm>
-            <a:off x="11751164" y="8050000"/>
-            <a:ext cx="1685582" cy="1500000"/>
+            <a:off x="11986364" y="8050000"/>
+            <a:ext cx="1803182" cy="1500000"/>
           </a:xfrm>
           <a:prstGeom prst="rect">
             <a:avLst/>
@@ -16999,8 +16999,8 @@
         </p:nvSpPr>
         <p:spPr>
           <a:xfrm>
-            <a:off x="13436746" y="8050000"/>
-            <a:ext cx="1685582" cy="1500000"/>
+            <a:off x="13789546" y="8050000"/>
+            <a:ext cx="1803182" cy="1500000"/>
           </a:xfrm>
           <a:prstGeom prst="rect">
             <a:avLst/>
@@ -17068,8 +17068,8 @@
         </p:nvSpPr>
         <p:spPr>
           <a:xfrm>
-            <a:off x="15122328" y="8050000"/>
-            <a:ext cx="1685582" cy="1500000"/>
+            <a:off x="15592728" y="8050000"/>
+            <a:ext cx="1803182" cy="1500000"/>
           </a:xfrm>
           <a:prstGeom prst="rect">
             <a:avLst/>
@@ -20257,7 +20257,7 @@
       </p:sp>
       <p:sp>
         <p:nvSpPr>
-          <p:cNvPr id="275" name="Riga 275"/>
+          <p:cNvPr id="275" name="Riga 275" descr="{{#servizi:alterna}}"/>
           <p:cNvSpPr/>
           <p:nvPr/>
         </p:nvSpPr>
@@ -20290,7 +20290,7 @@
       </p:sp>
       <p:sp>
         <p:nvSpPr>
-          <p:cNvPr id="276" name="Testo 276"/>
+          <p:cNvPr id="276" name="Testo 276" descr="{{#servizi}}"/>
           <p:cNvSpPr txBox="1"/>
           <p:nvPr/>
         </p:nvSpPr>
@@ -20326,14 +20326,14 @@
                 <a:cs typeface="Canva Sans"/>
                 <a:sym typeface="Canva Sans"/>
               </a:rPr>
-              <a:t>Trasporto in cantiere (scarico escluso)</a:t>
-            </a:r>
-          </a:p>
-        </p:txBody>
-      </p:sp>
-      <p:sp>
-        <p:nvSpPr>
-          <p:cNvPr id="277" name="Testo 277"/>
+              <a:t>{{voce}}</a:t>
+            </a:r>
+          </a:p>
+        </p:txBody>
+      </p:sp>
+      <p:sp>
+        <p:nvSpPr>
+          <p:cNvPr id="277" name="Testo 277" descr="{{#servizi}}"/>
           <p:cNvSpPr txBox="1"/>
           <p:nvPr/>
         </p:nvSpPr>
@@ -20369,708 +20369,7 @@
                 <a:cs typeface="Open Sauce Bold"/>
                 <a:sym typeface="Open Sauce Bold"/>
               </a:rPr>
-              <a:t>{{trasporto_opzionale}}</a:t>
-            </a:r>
-          </a:p>
-        </p:txBody>
-      </p:sp>
-      <p:sp>
-        <p:nvSpPr>
-          <p:cNvPr id="278" name="Testo 278"/>
-          <p:cNvSpPr txBox="1"/>
-          <p:nvPr/>
-        </p:nvSpPr>
-        <p:spPr>
-          <a:xfrm>
-            <a:off x="862089" y="3830000"/>
-            <a:ext cx="11300000" cy="620000"/>
-          </a:xfrm>
-          <a:prstGeom prst="rect">
-            <a:avLst/>
-          </a:prstGeom>
-          <a:noFill/>
-        </p:spPr>
-        <p:txBody>
-          <a:bodyPr wrap="square" lIns="0" tIns="0" rIns="0" bIns="0" rtlCol="0" anchor="ctr">
-            <a:noAutofit/>
-          </a:bodyPr>
-          <a:lstStyle/>
-          <a:p>
-            <a:pPr algn="l">
-              <a:spcAft>
-                <a:spcPts val="0"/>
-              </a:spcAft>
-              <a:buNone/>
-            </a:pPr>
-            <a:r>
-              <a:rPr lang="it-IT" sz="2000" dirty="0">
-                <a:solidFill>
-                  <a:srgbClr val="FFFFFF"/>
-                </a:solidFill>
-                <a:latin typeface="Canva Sans"/>
-                <a:ea typeface="Canva Sans"/>
-                <a:cs typeface="Canva Sans"/>
-                <a:sym typeface="Canva Sans"/>
-              </a:rPr>
-              <a:t>Posa in opera</a:t>
-            </a:r>
-          </a:p>
-        </p:txBody>
-      </p:sp>
-      <p:sp>
-        <p:nvSpPr>
-          <p:cNvPr id="279" name="Testo 279"/>
-          <p:cNvSpPr txBox="1"/>
-          <p:nvPr/>
-        </p:nvSpPr>
-        <p:spPr>
-          <a:xfrm>
-            <a:off x="12662089" y="3830000"/>
-            <a:ext cx="4763911" cy="620000"/>
-          </a:xfrm>
-          <a:prstGeom prst="rect">
-            <a:avLst/>
-          </a:prstGeom>
-          <a:noFill/>
-        </p:spPr>
-        <p:txBody>
-          <a:bodyPr wrap="square" lIns="0" tIns="0" rIns="0" bIns="0" rtlCol="0" anchor="ctr">
-            <a:noAutofit/>
-          </a:bodyPr>
-          <a:lstStyle/>
-          <a:p>
-            <a:pPr algn="ctr">
-              <a:spcAft>
-                <a:spcPts val="0"/>
-              </a:spcAft>
-              <a:buNone/>
-            </a:pPr>
-            <a:r>
-              <a:rPr lang="it-IT" sz="2000" b="1" dirty="0">
-                <a:solidFill>
-                  <a:srgbClr val="79E920"/>
-                </a:solidFill>
-                <a:latin typeface="Open Sauce Bold"/>
-                <a:ea typeface="Open Sauce Bold"/>
-                <a:cs typeface="Open Sauce Bold"/>
-                <a:sym typeface="Open Sauce Bold"/>
-              </a:rPr>
-              <a:t>{{posa_opzionale}}</a:t>
-            </a:r>
-          </a:p>
-        </p:txBody>
-      </p:sp>
-      <p:sp>
-        <p:nvSpPr>
-          <p:cNvPr id="280" name="Riga 280"/>
-          <p:cNvSpPr/>
-          <p:nvPr/>
-        </p:nvSpPr>
-        <p:spPr>
-          <a:xfrm>
-            <a:off x="612089" y="4450000"/>
-            <a:ext cx="17063911" cy="620000"/>
-          </a:xfrm>
-          <a:prstGeom prst="rect">
-            <a:avLst/>
-          </a:prstGeom>
-          <a:solidFill>
-            <a:srgbClr val="FFFFFF">
-              <a:alpha val="6000"/>
-            </a:srgbClr>
-          </a:solidFill>
-          <a:ln>
-            <a:noFill/>
-          </a:ln>
-        </p:spPr>
-        <p:txBody>
-          <a:bodyPr wrap="square" lIns="0" tIns="0" rIns="0" bIns="0" rtlCol="0" anchor="ctr">
-            <a:noAutofit/>
-          </a:bodyPr>
-          <a:lstStyle/>
-          <a:p>
-            <a:endParaRPr lang="it-IT"/>
-          </a:p>
-        </p:txBody>
-      </p:sp>
-      <p:sp>
-        <p:nvSpPr>
-          <p:cNvPr id="281" name="Testo 281"/>
-          <p:cNvSpPr txBox="1"/>
-          <p:nvPr/>
-        </p:nvSpPr>
-        <p:spPr>
-          <a:xfrm>
-            <a:off x="862089" y="4450000"/>
-            <a:ext cx="11300000" cy="620000"/>
-          </a:xfrm>
-          <a:prstGeom prst="rect">
-            <a:avLst/>
-          </a:prstGeom>
-          <a:noFill/>
-        </p:spPr>
-        <p:txBody>
-          <a:bodyPr wrap="square" lIns="0" tIns="0" rIns="0" bIns="0" rtlCol="0" anchor="ctr">
-            <a:noAutofit/>
-          </a:bodyPr>
-          <a:lstStyle/>
-          <a:p>
-            <a:pPr algn="l">
-              <a:spcAft>
-                <a:spcPts val="0"/>
-              </a:spcAft>
-              <a:buNone/>
-            </a:pPr>
-            <a:r>
-              <a:rPr lang="it-IT" sz="2000" dirty="0">
-                <a:solidFill>
-                  <a:srgbClr val="FFFFFF"/>
-                </a:solidFill>
-                <a:latin typeface="Canva Sans"/>
-                <a:ea typeface="Canva Sans"/>
-                <a:cs typeface="Canva Sans"/>
-                <a:sym typeface="Canva Sans"/>
-              </a:rPr>
-              <a:t>Ricambi di montaggio in fase di costruzione</a:t>
-            </a:r>
-          </a:p>
-        </p:txBody>
-      </p:sp>
-      <p:sp>
-        <p:nvSpPr>
-          <p:cNvPr id="282" name="Testo 282"/>
-          <p:cNvSpPr txBox="1"/>
-          <p:nvPr/>
-        </p:nvSpPr>
-        <p:spPr>
-          <a:xfrm>
-            <a:off x="12662089" y="4450000"/>
-            <a:ext cx="4763911" cy="620000"/>
-          </a:xfrm>
-          <a:prstGeom prst="rect">
-            <a:avLst/>
-          </a:prstGeom>
-          <a:noFill/>
-        </p:spPr>
-        <p:txBody>
-          <a:bodyPr wrap="square" lIns="0" tIns="0" rIns="0" bIns="0" rtlCol="0" anchor="ctr">
-            <a:noAutofit/>
-          </a:bodyPr>
-          <a:lstStyle/>
-          <a:p>
-            <a:pPr algn="ctr">
-              <a:spcAft>
-                <a:spcPts val="0"/>
-              </a:spcAft>
-              <a:buNone/>
-            </a:pPr>
-            <a:r>
-              <a:rPr lang="it-IT" sz="2000" b="1" dirty="0">
-                <a:solidFill>
-                  <a:srgbClr val="79E920"/>
-                </a:solidFill>
-                <a:latin typeface="Open Sauce Bold"/>
-                <a:ea typeface="Open Sauce Bold"/>
-                <a:cs typeface="Open Sauce Bold"/>
-                <a:sym typeface="Open Sauce Bold"/>
-              </a:rPr>
-              <a:t>Su richiesta</a:t>
-            </a:r>
-          </a:p>
-        </p:txBody>
-      </p:sp>
-      <p:sp>
-        <p:nvSpPr>
-          <p:cNvPr id="283" name="Testo 283"/>
-          <p:cNvSpPr txBox="1"/>
-          <p:nvPr/>
-        </p:nvSpPr>
-        <p:spPr>
-          <a:xfrm>
-            <a:off x="862089" y="5070000"/>
-            <a:ext cx="11300000" cy="620000"/>
-          </a:xfrm>
-          <a:prstGeom prst="rect">
-            <a:avLst/>
-          </a:prstGeom>
-          <a:noFill/>
-        </p:spPr>
-        <p:txBody>
-          <a:bodyPr wrap="square" lIns="0" tIns="0" rIns="0" bIns="0" rtlCol="0" anchor="ctr">
-            <a:noAutofit/>
-          </a:bodyPr>
-          <a:lstStyle/>
-          <a:p>
-            <a:pPr algn="l">
-              <a:spcAft>
-                <a:spcPts val="0"/>
-              </a:spcAft>
-              <a:buNone/>
-            </a:pPr>
-            <a:r>
-              <a:rPr lang="it-IT" sz="2000" dirty="0">
-                <a:solidFill>
-                  <a:srgbClr val="FFFFFF"/>
-                </a:solidFill>
-                <a:latin typeface="Canva Sans"/>
-                <a:ea typeface="Canva Sans"/>
-                <a:cs typeface="Canva Sans"/>
-                <a:sym typeface="Canva Sans"/>
-              </a:rPr>
-              <a:t>Ricambi O&amp;M (2 anni)</a:t>
-            </a:r>
-          </a:p>
-        </p:txBody>
-      </p:sp>
-      <p:sp>
-        <p:nvSpPr>
-          <p:cNvPr id="284" name="Testo 284"/>
-          <p:cNvSpPr txBox="1"/>
-          <p:nvPr/>
-        </p:nvSpPr>
-        <p:spPr>
-          <a:xfrm>
-            <a:off x="12662089" y="5070000"/>
-            <a:ext cx="4763911" cy="620000"/>
-          </a:xfrm>
-          <a:prstGeom prst="rect">
-            <a:avLst/>
-          </a:prstGeom>
-          <a:noFill/>
-        </p:spPr>
-        <p:txBody>
-          <a:bodyPr wrap="square" lIns="0" tIns="0" rIns="0" bIns="0" rtlCol="0" anchor="ctr">
-            <a:noAutofit/>
-          </a:bodyPr>
-          <a:lstStyle/>
-          <a:p>
-            <a:pPr algn="ctr">
-              <a:spcAft>
-                <a:spcPts val="0"/>
-              </a:spcAft>
-              <a:buNone/>
-            </a:pPr>
-            <a:r>
-              <a:rPr lang="it-IT" sz="2000" b="1" dirty="0">
-                <a:solidFill>
-                  <a:srgbClr val="79E920"/>
-                </a:solidFill>
-                <a:latin typeface="Open Sauce Bold"/>
-                <a:ea typeface="Open Sauce Bold"/>
-                <a:cs typeface="Open Sauce Bold"/>
-                <a:sym typeface="Open Sauce Bold"/>
-              </a:rPr>
-              <a:t>Su richiesta</a:t>
-            </a:r>
-          </a:p>
-        </p:txBody>
-      </p:sp>
-      <p:sp>
-        <p:nvSpPr>
-          <p:cNvPr id="285" name="Riga 285"/>
-          <p:cNvSpPr/>
-          <p:nvPr/>
-        </p:nvSpPr>
-        <p:spPr>
-          <a:xfrm>
-            <a:off x="612089" y="5690000"/>
-            <a:ext cx="17063911" cy="620000"/>
-          </a:xfrm>
-          <a:prstGeom prst="rect">
-            <a:avLst/>
-          </a:prstGeom>
-          <a:solidFill>
-            <a:srgbClr val="FFFFFF">
-              <a:alpha val="6000"/>
-            </a:srgbClr>
-          </a:solidFill>
-          <a:ln>
-            <a:noFill/>
-          </a:ln>
-        </p:spPr>
-        <p:txBody>
-          <a:bodyPr wrap="square" lIns="0" tIns="0" rIns="0" bIns="0" rtlCol="0" anchor="ctr">
-            <a:noAutofit/>
-          </a:bodyPr>
-          <a:lstStyle/>
-          <a:p>
-            <a:endParaRPr lang="it-IT"/>
-          </a:p>
-        </p:txBody>
-      </p:sp>
-      <p:sp>
-        <p:nvSpPr>
-          <p:cNvPr id="286" name="Testo 286"/>
-          <p:cNvSpPr txBox="1"/>
-          <p:nvPr/>
-        </p:nvSpPr>
-        <p:spPr>
-          <a:xfrm>
-            <a:off x="862089" y="5690000"/>
-            <a:ext cx="11300000" cy="620000"/>
-          </a:xfrm>
-          <a:prstGeom prst="rect">
-            <a:avLst/>
-          </a:prstGeom>
-          <a:noFill/>
-        </p:spPr>
-        <p:txBody>
-          <a:bodyPr wrap="square" lIns="0" tIns="0" rIns="0" bIns="0" rtlCol="0" anchor="ctr">
-            <a:noAutofit/>
-          </a:bodyPr>
-          <a:lstStyle/>
-          <a:p>
-            <a:pPr algn="l">
-              <a:spcAft>
-                <a:spcPts val="0"/>
-              </a:spcAft>
-              <a:buNone/>
-            </a:pPr>
-            <a:r>
-              <a:rPr lang="it-IT" sz="2000" dirty="0">
-                <a:solidFill>
-                  <a:srgbClr val="FFFFFF"/>
-                </a:solidFill>
-                <a:latin typeface="Canva Sans"/>
-                <a:ea typeface="Canva Sans"/>
-                <a:cs typeface="Canva Sans"/>
-                <a:sym typeface="Canva Sans"/>
-              </a:rPr>
-              <a:t>Pull-out test</a:t>
-            </a:r>
-          </a:p>
-        </p:txBody>
-      </p:sp>
-      <p:sp>
-        <p:nvSpPr>
-          <p:cNvPr id="287" name="Testo 287"/>
-          <p:cNvSpPr txBox="1"/>
-          <p:nvPr/>
-        </p:nvSpPr>
-        <p:spPr>
-          <a:xfrm>
-            <a:off x="12662089" y="5690000"/>
-            <a:ext cx="4763911" cy="620000"/>
-          </a:xfrm>
-          <a:prstGeom prst="rect">
-            <a:avLst/>
-          </a:prstGeom>
-          <a:noFill/>
-        </p:spPr>
-        <p:txBody>
-          <a:bodyPr wrap="square" lIns="0" tIns="0" rIns="0" bIns="0" rtlCol="0" anchor="ctr">
-            <a:noAutofit/>
-          </a:bodyPr>
-          <a:lstStyle/>
-          <a:p>
-            <a:pPr algn="ctr">
-              <a:spcAft>
-                <a:spcPts val="0"/>
-              </a:spcAft>
-              <a:buNone/>
-            </a:pPr>
-            <a:r>
-              <a:rPr lang="it-IT" sz="2000" b="1" dirty="0">
-                <a:solidFill>
-                  <a:srgbClr val="79E920"/>
-                </a:solidFill>
-                <a:latin typeface="Open Sauce Bold"/>
-                <a:ea typeface="Open Sauce Bold"/>
-                <a:cs typeface="Open Sauce Bold"/>
-                <a:sym typeface="Open Sauce Bold"/>
-              </a:rPr>
-              <a:t>Su richiesta</a:t>
-            </a:r>
-          </a:p>
-        </p:txBody>
-      </p:sp>
-      <p:sp>
-        <p:nvSpPr>
-          <p:cNvPr id="288" name="Testo 288"/>
-          <p:cNvSpPr txBox="1"/>
-          <p:nvPr/>
-        </p:nvSpPr>
-        <p:spPr>
-          <a:xfrm>
-            <a:off x="862089" y="6310000"/>
-            <a:ext cx="11300000" cy="620000"/>
-          </a:xfrm>
-          <a:prstGeom prst="rect">
-            <a:avLst/>
-          </a:prstGeom>
-          <a:noFill/>
-        </p:spPr>
-        <p:txBody>
-          <a:bodyPr wrap="square" lIns="0" tIns="0" rIns="0" bIns="0" rtlCol="0" anchor="ctr">
-            <a:noAutofit/>
-          </a:bodyPr>
-          <a:lstStyle/>
-          <a:p>
-            <a:pPr algn="l">
-              <a:spcAft>
-                <a:spcPts val="0"/>
-              </a:spcAft>
-              <a:buNone/>
-            </a:pPr>
-            <a:r>
-              <a:rPr lang="it-IT" sz="2000" dirty="0">
-                <a:solidFill>
-                  <a:srgbClr val="FFFFFF"/>
-                </a:solidFill>
-                <a:latin typeface="Canva Sans"/>
-                <a:ea typeface="Canva Sans"/>
-                <a:cs typeface="Canva Sans"/>
-                <a:sym typeface="Canva Sans"/>
-              </a:rPr>
-              <a:t>Supervisione al montaggio</a:t>
-            </a:r>
-          </a:p>
-        </p:txBody>
-      </p:sp>
-      <p:sp>
-        <p:nvSpPr>
-          <p:cNvPr id="289" name="Testo 289"/>
-          <p:cNvSpPr txBox="1"/>
-          <p:nvPr/>
-        </p:nvSpPr>
-        <p:spPr>
-          <a:xfrm>
-            <a:off x="12662089" y="6310000"/>
-            <a:ext cx="4763911" cy="620000"/>
-          </a:xfrm>
-          <a:prstGeom prst="rect">
-            <a:avLst/>
-          </a:prstGeom>
-          <a:noFill/>
-        </p:spPr>
-        <p:txBody>
-          <a:bodyPr wrap="square" lIns="0" tIns="0" rIns="0" bIns="0" rtlCol="0" anchor="ctr">
-            <a:noAutofit/>
-          </a:bodyPr>
-          <a:lstStyle/>
-          <a:p>
-            <a:pPr algn="ctr">
-              <a:spcAft>
-                <a:spcPts val="0"/>
-              </a:spcAft>
-              <a:buNone/>
-            </a:pPr>
-            <a:r>
-              <a:rPr lang="it-IT" sz="2000" b="1" dirty="0">
-                <a:solidFill>
-                  <a:srgbClr val="79E920"/>
-                </a:solidFill>
-                <a:latin typeface="Open Sauce Bold"/>
-                <a:ea typeface="Open Sauce Bold"/>
-                <a:cs typeface="Open Sauce Bold"/>
-                <a:sym typeface="Open Sauce Bold"/>
-              </a:rPr>
-              <a:t>Su richiesta</a:t>
-            </a:r>
-          </a:p>
-        </p:txBody>
-      </p:sp>
-      <p:sp>
-        <p:nvSpPr>
-          <p:cNvPr id="290" name="Riga 290"/>
-          <p:cNvSpPr/>
-          <p:nvPr/>
-        </p:nvSpPr>
-        <p:spPr>
-          <a:xfrm>
-            <a:off x="612089" y="6930000"/>
-            <a:ext cx="17063911" cy="620000"/>
-          </a:xfrm>
-          <a:prstGeom prst="rect">
-            <a:avLst/>
-          </a:prstGeom>
-          <a:solidFill>
-            <a:srgbClr val="FFFFFF">
-              <a:alpha val="6000"/>
-            </a:srgbClr>
-          </a:solidFill>
-          <a:ln>
-            <a:noFill/>
-          </a:ln>
-        </p:spPr>
-        <p:txBody>
-          <a:bodyPr wrap="square" lIns="0" tIns="0" rIns="0" bIns="0" rtlCol="0" anchor="ctr">
-            <a:noAutofit/>
-          </a:bodyPr>
-          <a:lstStyle/>
-          <a:p>
-            <a:endParaRPr lang="it-IT"/>
-          </a:p>
-        </p:txBody>
-      </p:sp>
-      <p:sp>
-        <p:nvSpPr>
-          <p:cNvPr id="291" name="Testo 291"/>
-          <p:cNvSpPr txBox="1"/>
-          <p:nvPr/>
-        </p:nvSpPr>
-        <p:spPr>
-          <a:xfrm>
-            <a:off x="862089" y="6930000"/>
-            <a:ext cx="11300000" cy="620000"/>
-          </a:xfrm>
-          <a:prstGeom prst="rect">
-            <a:avLst/>
-          </a:prstGeom>
-          <a:noFill/>
-        </p:spPr>
-        <p:txBody>
-          <a:bodyPr wrap="square" lIns="0" tIns="0" rIns="0" bIns="0" rtlCol="0" anchor="ctr">
-            <a:noAutofit/>
-          </a:bodyPr>
-          <a:lstStyle/>
-          <a:p>
-            <a:pPr algn="l">
-              <a:spcAft>
-                <a:spcPts val="0"/>
-              </a:spcAft>
-              <a:buNone/>
-            </a:pPr>
-            <a:r>
-              <a:rPr lang="it-IT" sz="2000" dirty="0">
-                <a:solidFill>
-                  <a:srgbClr val="FFFFFF"/>
-                </a:solidFill>
-                <a:latin typeface="Canva Sans"/>
-                <a:ea typeface="Canva Sans"/>
-                <a:cs typeface="Canva Sans"/>
-                <a:sym typeface="Canva Sans"/>
-              </a:rPr>
-              <a:t>Commissioning in sito</a:t>
-            </a:r>
-          </a:p>
-        </p:txBody>
-      </p:sp>
-      <p:sp>
-        <p:nvSpPr>
-          <p:cNvPr id="292" name="Testo 292"/>
-          <p:cNvSpPr txBox="1"/>
-          <p:nvPr/>
-        </p:nvSpPr>
-        <p:spPr>
-          <a:xfrm>
-            <a:off x="12662089" y="6930000"/>
-            <a:ext cx="4763911" cy="620000"/>
-          </a:xfrm>
-          <a:prstGeom prst="rect">
-            <a:avLst/>
-          </a:prstGeom>
-          <a:noFill/>
-        </p:spPr>
-        <p:txBody>
-          <a:bodyPr wrap="square" lIns="0" tIns="0" rIns="0" bIns="0" rtlCol="0" anchor="ctr">
-            <a:noAutofit/>
-          </a:bodyPr>
-          <a:lstStyle/>
-          <a:p>
-            <a:pPr algn="ctr">
-              <a:spcAft>
-                <a:spcPts val="0"/>
-              </a:spcAft>
-              <a:buNone/>
-            </a:pPr>
-            <a:r>
-              <a:rPr lang="it-IT" sz="2000" b="1" dirty="0">
-                <a:solidFill>
-                  <a:srgbClr val="79E920"/>
-                </a:solidFill>
-                <a:latin typeface="Open Sauce Bold"/>
-                <a:ea typeface="Open Sauce Bold"/>
-                <a:cs typeface="Open Sauce Bold"/>
-                <a:sym typeface="Open Sauce Bold"/>
-              </a:rPr>
-              <a:t>Su richiesta</a:t>
-            </a:r>
-          </a:p>
-        </p:txBody>
-      </p:sp>
-      <p:sp>
-        <p:nvSpPr>
-          <p:cNvPr id="293" name="Testo 293"/>
-          <p:cNvSpPr txBox="1"/>
-          <p:nvPr/>
-        </p:nvSpPr>
-        <p:spPr>
-          <a:xfrm>
-            <a:off x="862089" y="7550000"/>
-            <a:ext cx="11300000" cy="620000"/>
-          </a:xfrm>
-          <a:prstGeom prst="rect">
-            <a:avLst/>
-          </a:prstGeom>
-          <a:noFill/>
-        </p:spPr>
-        <p:txBody>
-          <a:bodyPr wrap="square" lIns="0" tIns="0" rIns="0" bIns="0" rtlCol="0" anchor="ctr">
-            <a:noAutofit/>
-          </a:bodyPr>
-          <a:lstStyle/>
-          <a:p>
-            <a:pPr algn="l">
-              <a:spcAft>
-                <a:spcPts val="0"/>
-              </a:spcAft>
-              <a:buNone/>
-            </a:pPr>
-            <a:r>
-              <a:rPr lang="it-IT" sz="2000" dirty="0">
-                <a:solidFill>
-                  <a:srgbClr val="FFFFFF"/>
-                </a:solidFill>
-                <a:latin typeface="Canva Sans"/>
-                <a:ea typeface="Canva Sans"/>
-                <a:cs typeface="Canva Sans"/>
-                <a:sym typeface="Canva Sans"/>
-              </a:rPr>
-              <a:t>Prolunga pali (+10 cm)</a:t>
-            </a:r>
-          </a:p>
-        </p:txBody>
-      </p:sp>
-      <p:sp>
-        <p:nvSpPr>
-          <p:cNvPr id="294" name="Testo 294"/>
-          <p:cNvSpPr txBox="1"/>
-          <p:nvPr/>
-        </p:nvSpPr>
-        <p:spPr>
-          <a:xfrm>
-            <a:off x="12662089" y="7550000"/>
-            <a:ext cx="4763911" cy="620000"/>
-          </a:xfrm>
-          <a:prstGeom prst="rect">
-            <a:avLst/>
-          </a:prstGeom>
-          <a:noFill/>
-        </p:spPr>
-        <p:txBody>
-          <a:bodyPr wrap="square" lIns="0" tIns="0" rIns="0" bIns="0" rtlCol="0" anchor="ctr">
-            <a:noAutofit/>
-          </a:bodyPr>
-          <a:lstStyle/>
-          <a:p>
-            <a:pPr algn="ctr">
-              <a:spcAft>
-                <a:spcPts val="0"/>
-              </a:spcAft>
-              <a:buNone/>
-            </a:pPr>
-            <a:r>
-              <a:rPr lang="it-IT" sz="2000" b="1" dirty="0">
-                <a:solidFill>
-                  <a:srgbClr val="79E920"/>
-                </a:solidFill>
-                <a:latin typeface="Open Sauce Bold"/>
-                <a:ea typeface="Open Sauce Bold"/>
-                <a:cs typeface="Open Sauce Bold"/>
-                <a:sym typeface="Open Sauce Bold"/>
-              </a:rPr>
-              <a:t>Su richiesta</a:t>
+              <a:t>{{prezzo}}</a:t>
             </a:r>
           </a:p>
         </p:txBody>

</xml_diff>